<commit_message>
docs: switch proposal to Manrope with shadcn-style charts
Co-Authored-By: Claude Opus 5.5 <noreply@anthropic.com>
Claude-Session: https://claude.ai/code/session_01RtzqifrKjueqJTPghCpXb1
</commit_message>
<xml_diff>
--- a/docs/proposal/Darubini-Proposal.pptx
+++ b/docs/proposal/Darubini-Proposal.pptx
@@ -118,34 +118,34 @@
   <p:extLst>
     <p:ext uri="{521415D9-36F7-43E2-AB2F-B90AF26B5E84}">
       <p14:sectionLst xmlns:p14="http://schemas.microsoft.com/office/powerpoint/2010/main">
-        <p14:section name="Opening" id="{9c514609-f89f-0b8e-fe32-5a8e88984dc7}">
+        <p14:section name="Opening" id="{cb2f652c-5973-9cf0-25b4-2c9ae2d8ce04}">
           <p14:sldIdLst>
             <p14:sldId id="256"/>
           </p14:sldIdLst>
         </p14:section>
-        <p14:section name="Problem" id="{a7477e34-4660-9c47-020b-270a62a1f631}">
+        <p14:section name="Problem" id="{a7ac4e4d-3e51-babc-d0dc-22260aab6caf}">
           <p14:sldIdLst>
             <p14:sldId id="257"/>
           </p14:sldIdLst>
         </p14:section>
-        <p14:section name="Solution" id="{15c6ded6-5643-2850-0aaf-86d126618f45}">
+        <p14:section name="Solution" id="{a13a8245-665d-53ac-49ca-58a80a0270e1}">
           <p14:sldIdLst>
             <p14:sldId id="258"/>
             <p14:sldId id="259"/>
           </p14:sldIdLst>
         </p14:section>
-        <p14:section name="Meta AI" id="{e5d49566-06ff-1971-775e-254d107a7677}">
+        <p14:section name="Meta AI" id="{ec6752bd-07aa-0385-af7e-4a005504e00e}">
           <p14:sldIdLst>
             <p14:sldId id="260"/>
           </p14:sldIdLst>
         </p14:section>
-        <p14:section name="Data and evaluation" id="{ca9891ef-c979-9678-a0af-c60acaf26120}">
+        <p14:section name="Data and evaluation" id="{c5abde9a-2404-69ed-5dc5-093a68274241}">
           <p14:sldIdLst>
             <p14:sldId id="261"/>
             <p14:sldId id="262"/>
           </p14:sldIdLst>
         </p14:section>
-        <p14:section name="Strategy" id="{72db2a73-0378-4489-6ac6-21d406734b34}">
+        <p14:section name="Strategy" id="{59f9ff72-da16-f0c7-d248-7d59e2420a3d}">
           <p14:sldIdLst>
             <p14:sldId id="263"/>
             <p14:sldId id="264"/>
@@ -153,7 +153,7 @@
             <p14:sldId id="266"/>
           </p14:sldIdLst>
         </p14:section>
-        <p14:section name="Close" id="{33607bbd-f1a3-d88b-3c36-096b1422d238}">
+        <p14:section name="Close" id="{5e2293db-4895-773b-b5e5-aaec23e8936d}">
           <p14:sldIdLst>
             <p14:sldId id="267"/>
           </p14:sldIdLst>
@@ -172,36 +172,7 @@
   <c:date1904 val="0"/>
   <c:roundedCorners val="1"/>
   <c:chart>
-    <c:title>
-      <c:tx>
-        <c:rich>
-          <a:bodyPr/>
-          <a:lstStyle/>
-          <a:p>
-            <a:pPr>
-              <a:defRPr sz="1400" b="0" i="0" u="none" strike="noStrike">
-                <a:solidFill>
-                  <a:srgbClr val="64748B"/>
-                </a:solidFill>
-                <a:latin typeface="+mn-lt"/>
-              </a:defRPr>
-            </a:pPr>
-            <a:r>
-              <a:rPr sz="1400" b="0" i="0" u="none" strike="noStrike">
-                <a:solidFill>
-                  <a:srgbClr val="64748B"/>
-                </a:solidFill>
-                <a:latin typeface="+mn-lt"/>
-              </a:rPr>
-              <a:t>Judging weights (%)</a:t>
-            </a:r>
-          </a:p>
-        </c:rich>
-      </c:tx>
-      <c:layout/>
-      <c:overlay val="0"/>
-    </c:title>
-    <c:autoTitleDeleted val="0"/>
+    <c:autoTitleDeleted val="1"/>
     <c:plotArea>
       <c:layout/>
       <c:barChart>
@@ -236,7 +207,7 @@
               <a:lstStyle/>
               <a:p>
                 <a:pPr>
-                  <a:defRPr b="1" i="0" strike="noStrike" sz="1400" u="none">
+                  <a:defRPr b="1" i="0" strike="noStrike" sz="1200" u="none">
                     <a:solidFill>
                       <a:srgbClr val="0F172A"/>
                     </a:solidFill>
@@ -270,7 +241,7 @@
             <c:bubble3D val="0"/>
             <c:spPr>
               <a:solidFill>
-                <a:srgbClr val="6D3FA0"/>
+                <a:srgbClr val="3B82F6"/>
               </a:solidFill>
               <a:effectLst/>
             </c:spPr>
@@ -281,7 +252,7 @@
             <c:bubble3D val="0"/>
             <c:spPr>
               <a:solidFill>
-                <a:srgbClr val="16A34A"/>
+                <a:srgbClr val="60A5FA"/>
               </a:solidFill>
               <a:effectLst/>
             </c:spPr>
@@ -292,7 +263,7 @@
             <c:bubble3D val="0"/>
             <c:spPr>
               <a:solidFill>
-                <a:srgbClr val="D97706"/>
+                <a:srgbClr val="93C5FD"/>
               </a:solidFill>
               <a:effectLst/>
             </c:spPr>
@@ -348,7 +319,7 @@
             <a:lstStyle/>
             <a:p>
               <a:pPr>
-                <a:defRPr b="1" i="0" strike="noStrike" sz="1400" u="none">
+                <a:defRPr b="1" i="0" strike="noStrike" sz="1200" u="none">
                   <a:solidFill>
                     <a:srgbClr val="0F172A"/>
                   </a:solidFill>
@@ -365,7 +336,7 @@
           <c:showBubbleSize val="0"/>
           <c:showLeaderLines val="0"/>
         </c:dLbls>
-        <c:gapWidth val="60"/>
+        <c:gapWidth val="45"/>
         <c:overlap val="0"/>
         <c:axId val="2094734554"/>
         <c:axId val="2094734552"/>
@@ -379,14 +350,12 @@
         <c:delete val="0"/>
         <c:axPos val="l"/>
         <c:numFmt formatCode="General" sourceLinked="1"/>
-        <c:majorTickMark val="out"/>
+        <c:majorTickMark val="none"/>
         <c:minorTickMark val="none"/>
         <c:tickLblPos val="nextTo"/>
         <c:spPr>
           <a:ln w="12700" cap="flat">
-            <a:solidFill>
-              <a:srgbClr val="888888"/>
-            </a:solidFill>
+            <a:noFill/>
             <a:prstDash val="solid"/>
             <a:round/>
           </a:ln>
@@ -396,9 +365,9 @@
           <a:lstStyle/>
           <a:p>
             <a:pPr>
-              <a:defRPr sz="1400" b="0" i="0" u="none" strike="noStrike">
-                <a:solidFill>
-                  <a:srgbClr val="0F172A"/>
+              <a:defRPr sz="1200" b="0" i="0" u="none" strike="noStrike">
+                <a:solidFill>
+                  <a:srgbClr val="64748B"/>
                 </a:solidFill>
                 <a:latin typeface="+mn-lt"/>
               </a:defRPr>
@@ -416,20 +385,29 @@
         <c:axId val="2094734552"/>
         <c:scaling>
           <c:orientation val="minMax"/>
-          <c:max val="36"/>
+          <c:max val="35"/>
           <c:min val="0"/>
         </c:scaling>
-        <c:delete val="1"/>
+        <c:delete val="0"/>
         <c:axPos val="b"/>
-        <c:numFmt formatCode="General" sourceLinked="0"/>
-        <c:majorTickMark val="out"/>
+        <c:majorGridlines>
+          <c:spPr>
+            <a:ln w="12700" cap="flat">
+              <a:solidFill>
+                <a:srgbClr val="E2E8F0"/>
+              </a:solidFill>
+              <a:prstDash val="dash"/>
+              <a:round/>
+            </a:ln>
+          </c:spPr>
+        </c:majorGridlines>
+        <c:numFmt formatCode="0" sourceLinked="0"/>
+        <c:majorTickMark val="none"/>
         <c:minorTickMark val="none"/>
         <c:tickLblPos val="low"/>
         <c:spPr>
           <a:ln w="12700" cap="flat">
-            <a:solidFill>
-              <a:srgbClr val="888888"/>
-            </a:solidFill>
+            <a:noFill/>
             <a:prstDash val="solid"/>
             <a:round/>
           </a:ln>
@@ -439,11 +417,11 @@
           <a:lstStyle/>
           <a:p>
             <a:pPr>
-              <a:defRPr sz="1200" b="0" i="0" u="none" strike="noStrike">
-                <a:solidFill>
-                  <a:srgbClr val="000000"/>
-                </a:solidFill>
-                <a:latin typeface="Arial"/>
+              <a:defRPr sz="1100" b="0" i="0" u="none" strike="noStrike">
+                <a:solidFill>
+                  <a:srgbClr val="64748B"/>
+                </a:solidFill>
+                <a:latin typeface="+mn-lt"/>
               </a:defRPr>
             </a:pPr>
             <a:endParaRPr lang="en-US"/>
@@ -452,6 +430,7 @@
         <c:crossAx val="2094734554"/>
         <c:crosses val="autoZero"/>
         <c:crossBetween val="between"/>
+        <c:majorUnit val="10"/>
       </c:valAx>
       <c:spPr>
         <a:noFill/>
@@ -11844,15 +11823,114 @@
           </a:p>
         </p:txBody>
       </p:sp>
+      <p:sp>
+        <p:nvSpPr>
+          <p:cNvPr id="4" name="chart-card"/>
+          <p:cNvSpPr/>
+          <p:nvPr/>
+        </p:nvSpPr>
+        <p:spPr>
+          <a:xfrm>
+            <a:off x="548640" y="1737360"/>
+            <a:ext cx="5120640" cy="4343400"/>
+          </a:xfrm>
+          <a:prstGeom prst="roundRect">
+            <a:avLst>
+              <a:gd name="adj" fmla="val 2105"/>
+            </a:avLst>
+          </a:prstGeom>
+          <a:solidFill>
+            <a:schemeClr val="bg1"/>
+          </a:solidFill>
+          <a:ln w="12700">
+            <a:solidFill>
+              <a:schemeClr val="accent6"/>
+            </a:solidFill>
+            <a:prstDash val="solid"/>
+          </a:ln>
+        </p:spPr>
+      </p:sp>
+      <p:sp>
+        <p:nvSpPr>
+          <p:cNvPr id="5" name="Text 3"/>
+          <p:cNvSpPr txBox="1"/>
+          <p:nvPr/>
+        </p:nvSpPr>
+        <p:spPr>
+          <a:xfrm>
+            <a:off x="868680" y="1965960"/>
+            <a:ext cx="4572000" cy="320040"/>
+          </a:xfrm>
+          <a:prstGeom prst="rect">
+            <a:avLst/>
+          </a:prstGeom>
+          <a:noFill/>
+          <a:ln/>
+        </p:spPr>
+        <p:txBody>
+          <a:bodyPr wrap="square" lIns="0" tIns="0" rIns="0" bIns="0" rtlCol="0" anchor="t"/>
+          <a:lstStyle/>
+          <a:p>
+            <a:pPr indent="0" marL="0">
+              <a:buNone/>
+            </a:pPr>
+            <a:r>
+              <a:rPr lang="en-US" sz="1600" b="1" dirty="0">
+                <a:solidFill>
+                  <a:schemeClr val="tx1"/>
+                </a:solidFill>
+              </a:rPr>
+              <a:t>Judging weights</a:t>
+            </a:r>
+            <a:endParaRPr lang="en-US" sz="1600" dirty="0"/>
+          </a:p>
+        </p:txBody>
+      </p:sp>
+      <p:sp>
+        <p:nvSpPr>
+          <p:cNvPr id="6" name="Text 4"/>
+          <p:cNvSpPr txBox="1"/>
+          <p:nvPr/>
+        </p:nvSpPr>
+        <p:spPr>
+          <a:xfrm>
+            <a:off x="868680" y="2286000"/>
+            <a:ext cx="4572000" cy="274320"/>
+          </a:xfrm>
+          <a:prstGeom prst="rect">
+            <a:avLst/>
+          </a:prstGeom>
+          <a:noFill/>
+          <a:ln/>
+        </p:spPr>
+        <p:txBody>
+          <a:bodyPr wrap="square" lIns="0" tIns="0" rIns="0" bIns="0" rtlCol="0" anchor="t"/>
+          <a:lstStyle/>
+          <a:p>
+            <a:pPr indent="0" marL="0">
+              <a:buNone/>
+            </a:pPr>
+            <a:r>
+              <a:rPr lang="en-US" sz="1200" dirty="0">
+                <a:solidFill>
+                  <a:schemeClr val="accent5"/>
+                </a:solidFill>
+              </a:rPr>
+              <a:t>Share of the final project score, per the Official Rules</a:t>
+            </a:r>
+            <a:endParaRPr lang="en-US" sz="1200" dirty="0"/>
+          </a:p>
+        </p:txBody>
+      </p:sp>
       <p:graphicFrame>
         <p:nvGraphicFramePr>
-          <p:cNvPr id="4" name="weights-chart" descr=""/>
+          <p:cNvPr id="7" name="weights-chart" descr=""/>
           <p:cNvGraphicFramePr/>
           <p:nvPr/>
         </p:nvGraphicFramePr>
         <p:xfrm>
-          <a:off x="548640" y="1737360"/>
-          <a:ext cx="4937760" cy="4114800"/>
+          <a:off x="685800" y="2606040"/>
+          <a:ext cx="4846320" cy="2697480"/>
         </p:xfrm>
         <a:graphic xmlns:a="http://schemas.openxmlformats.org/drawingml/2006/main">
           <a:graphicData uri="http://schemas.openxmlformats.org/drawingml/2006/chart">
@@ -11862,122 +11940,14 @@
       </p:graphicFrame>
       <p:sp>
         <p:nvSpPr>
-          <p:cNvPr id="5" name="Text 2"/>
-          <p:cNvSpPr txBox="1"/>
-          <p:nvPr/>
-        </p:nvSpPr>
-        <p:spPr>
-          <a:xfrm>
-            <a:off x="5943600" y="1783080"/>
-            <a:ext cx="5669280" cy="347472"/>
-          </a:xfrm>
-          <a:prstGeom prst="rect">
-            <a:avLst/>
-          </a:prstGeom>
-          <a:noFill/>
-          <a:ln/>
-        </p:spPr>
-        <p:txBody>
-          <a:bodyPr wrap="square" lIns="0" tIns="0" rIns="0" bIns="0" rtlCol="0" anchor="t"/>
-          <a:lstStyle/>
-          <a:p>
-            <a:pPr indent="0" marL="0">
-              <a:buNone/>
-            </a:pPr>
-            <a:r>
-              <a:rPr lang="en-US" sz="1700" b="1" dirty="0">
-                <a:solidFill>
-                  <a:schemeClr val="tx1"/>
-                </a:solidFill>
-              </a:rPr>
-              <a:t>Impact · 30%</a:t>
-            </a:r>
-            <a:endParaRPr lang="en-US" sz="1700" dirty="0"/>
-          </a:p>
-        </p:txBody>
-      </p:sp>
-      <p:sp>
-        <p:nvSpPr>
-          <p:cNvPr id="6" name="Text 3"/>
-          <p:cNvSpPr txBox="1"/>
-          <p:nvPr/>
-        </p:nvSpPr>
-        <p:spPr>
-          <a:xfrm>
-            <a:off x="5943600" y="2148840"/>
-            <a:ext cx="5669280" cy="548640"/>
-          </a:xfrm>
-          <a:prstGeom prst="rect">
-            <a:avLst/>
-          </a:prstGeom>
-          <a:noFill/>
-          <a:ln/>
-        </p:spPr>
-        <p:txBody>
-          <a:bodyPr wrap="square" lIns="0" tIns="0" rIns="0" bIns="0" rtlCol="0" anchor="t"/>
-          <a:lstStyle/>
-          <a:p>
-            <a:pPr indent="0" marL="0">
-              <a:buNone/>
-            </a:pPr>
-            <a:r>
-              <a:rPr lang="en-US" sz="1400" dirty="0">
-                <a:solidFill>
-                  <a:schemeClr val="accent5"/>
-                </a:solidFill>
-              </a:rPr>
-              <a:t>A leading killer in Tanzania, existing microscopes, a Kiswahili report, results on local slides.</a:t>
-            </a:r>
-            <a:endParaRPr lang="en-US" sz="1400" dirty="0"/>
-          </a:p>
-        </p:txBody>
-      </p:sp>
-      <p:sp>
-        <p:nvSpPr>
-          <p:cNvPr id="7" name="Text 4"/>
-          <p:cNvSpPr txBox="1"/>
-          <p:nvPr/>
-        </p:nvSpPr>
-        <p:spPr>
-          <a:xfrm>
-            <a:off x="5943600" y="2807208"/>
-            <a:ext cx="5669280" cy="347472"/>
-          </a:xfrm>
-          <a:prstGeom prst="rect">
-            <a:avLst/>
-          </a:prstGeom>
-          <a:noFill/>
-          <a:ln/>
-        </p:spPr>
-        <p:txBody>
-          <a:bodyPr wrap="square" lIns="0" tIns="0" rIns="0" bIns="0" rtlCol="0" anchor="t"/>
-          <a:lstStyle/>
-          <a:p>
-            <a:pPr indent="0" marL="0">
-              <a:buNone/>
-            </a:pPr>
-            <a:r>
-              <a:rPr lang="en-US" sz="1700" b="1" dirty="0">
-                <a:solidFill>
-                  <a:schemeClr val="tx1"/>
-                </a:solidFill>
-              </a:rPr>
-              <a:t>Meta tooling · 25%</a:t>
-            </a:r>
-            <a:endParaRPr lang="en-US" sz="1700" dirty="0"/>
-          </a:p>
-        </p:txBody>
-      </p:sp>
-      <p:sp>
-        <p:nvSpPr>
           <p:cNvPr id="8" name="Text 5"/>
           <p:cNvSpPr txBox="1"/>
           <p:nvPr/>
         </p:nvSpPr>
         <p:spPr>
           <a:xfrm>
-            <a:off x="5943600" y="3172968"/>
-            <a:ext cx="5669280" cy="548640"/>
+            <a:off x="868680" y="5440680"/>
+            <a:ext cx="4572000" cy="274320"/>
           </a:xfrm>
           <a:prstGeom prst="rect">
             <a:avLst/>
@@ -11993,14 +11963,14 @@
               <a:buNone/>
             </a:pPr>
             <a:r>
-              <a:rPr lang="en-US" sz="1400" dirty="0">
-                <a:solidFill>
-                  <a:schemeClr val="accent5"/>
-                </a:solidFill>
-              </a:rPr>
-              <a:t>Exemplar prompting, video tracking, Muse Spark as a tool-calling agent.</a:t>
-            </a:r>
-            <a:endParaRPr lang="en-US" sz="1400" dirty="0"/>
+              <a:rPr lang="en-US" sz="1300" b="1" dirty="0">
+                <a:solidFill>
+                  <a:schemeClr val="tx1"/>
+                </a:solidFill>
+              </a:rPr>
+              <a:t>Impact and the live demo carry 55% between them</a:t>
+            </a:r>
+            <a:endParaRPr lang="en-US" sz="1300" dirty="0"/>
           </a:p>
         </p:txBody>
       </p:sp>
@@ -12012,8 +11982,8 @@
         </p:nvSpPr>
         <p:spPr>
           <a:xfrm>
-            <a:off x="5943600" y="3831336"/>
-            <a:ext cx="5669280" cy="347472"/>
+            <a:off x="868680" y="5715000"/>
+            <a:ext cx="4572000" cy="274320"/>
           </a:xfrm>
           <a:prstGeom prst="rect">
             <a:avLst/>
@@ -12029,52 +11999,38 @@
               <a:buNone/>
             </a:pPr>
             <a:r>
-              <a:rPr lang="en-US" sz="1700" b="1" dirty="0">
-                <a:solidFill>
-                  <a:schemeClr val="tx1"/>
-                </a:solidFill>
-              </a:rPr>
-              <a:t>Demo · 25%</a:t>
-            </a:r>
-            <a:endParaRPr lang="en-US" sz="1700" dirty="0"/>
-          </a:p>
-        </p:txBody>
-      </p:sp>
-      <p:sp>
-        <p:nvSpPr>
-          <p:cNvPr id="10" name="Text 7"/>
-          <p:cNvSpPr txBox="1"/>
-          <p:nvPr/>
-        </p:nvSpPr>
-        <p:spPr>
-          <a:xfrm>
-            <a:off x="5943600" y="4197096"/>
-            <a:ext cx="5669280" cy="548640"/>
-          </a:xfrm>
-          <a:prstGeom prst="rect">
-            <a:avLst/>
-          </a:prstGeom>
-          <a:noFill/>
-          <a:ln/>
-        </p:spPr>
-        <p:txBody>
-          <a:bodyPr wrap="square" lIns="0" tIns="0" rIns="0" bIns="0" rtlCol="0" anchor="t"/>
-          <a:lstStyle/>
-          <a:p>
-            <a:pPr indent="0" marL="0">
-              <a:buNone/>
-            </a:pPr>
-            <a:r>
-              <a:rPr lang="en-US" sz="1400" dirty="0">
+              <a:rPr lang="en-US" sz="1200" dirty="0">
                 <a:solidFill>
                   <a:schemeClr val="accent5"/>
                 </a:solidFill>
               </a:rPr>
-              <a:t>Live on a real microscope, beside a microscopist's manual count.</a:t>
-            </a:r>
-            <a:endParaRPr lang="en-US" sz="1400" dirty="0"/>
-          </a:p>
-        </p:txBody>
+              <a:t>Meta tooling is weighted above technical depth</a:t>
+            </a:r>
+            <a:endParaRPr lang="en-US" sz="1200" dirty="0"/>
+          </a:p>
+        </p:txBody>
+      </p:sp>
+      <p:sp>
+        <p:nvSpPr>
+          <p:cNvPr id="10" name="legend-dot"/>
+          <p:cNvSpPr/>
+          <p:nvPr/>
+        </p:nvSpPr>
+        <p:spPr>
+          <a:xfrm>
+            <a:off x="5943600" y="1883664"/>
+            <a:ext cx="146304" cy="146304"/>
+          </a:xfrm>
+          <a:prstGeom prst="roundRect">
+            <a:avLst>
+              <a:gd name="adj" fmla="val 18750"/>
+            </a:avLst>
+          </a:prstGeom>
+          <a:solidFill>
+            <a:srgbClr val="2563EB"/>
+          </a:solidFill>
+          <a:ln/>
+        </p:spPr>
       </p:sp>
       <p:sp>
         <p:nvSpPr>
@@ -12084,8 +12040,8 @@
         </p:nvSpPr>
         <p:spPr>
           <a:xfrm>
-            <a:off x="5943600" y="4855464"/>
-            <a:ext cx="5669280" cy="347472"/>
+            <a:off x="6217920" y="1783080"/>
+            <a:ext cx="5394960" cy="347472"/>
           </a:xfrm>
           <a:prstGeom prst="rect">
             <a:avLst/>
@@ -12106,7 +12062,7 @@
                   <a:schemeClr val="tx1"/>
                 </a:solidFill>
               </a:rPr>
-              <a:t>Technical depth · 20%</a:t>
+              <a:t>Impact · 30%</a:t>
             </a:r>
             <a:endParaRPr lang="en-US" sz="1700" dirty="0"/>
           </a:p>
@@ -12120,8 +12076,290 @@
         </p:nvSpPr>
         <p:spPr>
           <a:xfrm>
-            <a:off x="5943600" y="5221224"/>
-            <a:ext cx="5669280" cy="548640"/>
+            <a:off x="6217920" y="2148840"/>
+            <a:ext cx="5394960" cy="548640"/>
+          </a:xfrm>
+          <a:prstGeom prst="rect">
+            <a:avLst/>
+          </a:prstGeom>
+          <a:noFill/>
+          <a:ln/>
+        </p:spPr>
+        <p:txBody>
+          <a:bodyPr wrap="square" lIns="0" tIns="0" rIns="0" bIns="0" rtlCol="0" anchor="t"/>
+          <a:lstStyle/>
+          <a:p>
+            <a:pPr indent="0" marL="0">
+              <a:buNone/>
+            </a:pPr>
+            <a:r>
+              <a:rPr lang="en-US" sz="1400" dirty="0">
+                <a:solidFill>
+                  <a:schemeClr val="accent5"/>
+                </a:solidFill>
+              </a:rPr>
+              <a:t>A leading killer in Tanzania, existing microscopes, a Kiswahili report, results on local slides.</a:t>
+            </a:r>
+            <a:endParaRPr lang="en-US" sz="1400" dirty="0"/>
+          </a:p>
+        </p:txBody>
+      </p:sp>
+      <p:sp>
+        <p:nvSpPr>
+          <p:cNvPr id="13" name="legend-dot"/>
+          <p:cNvSpPr/>
+          <p:nvPr/>
+        </p:nvSpPr>
+        <p:spPr>
+          <a:xfrm>
+            <a:off x="5943600" y="2907792"/>
+            <a:ext cx="146304" cy="146304"/>
+          </a:xfrm>
+          <a:prstGeom prst="roundRect">
+            <a:avLst>
+              <a:gd name="adj" fmla="val 18750"/>
+            </a:avLst>
+          </a:prstGeom>
+          <a:solidFill>
+            <a:srgbClr val="3B82F6"/>
+          </a:solidFill>
+          <a:ln/>
+        </p:spPr>
+      </p:sp>
+      <p:sp>
+        <p:nvSpPr>
+          <p:cNvPr id="14" name="Text 11"/>
+          <p:cNvSpPr txBox="1"/>
+          <p:nvPr/>
+        </p:nvSpPr>
+        <p:spPr>
+          <a:xfrm>
+            <a:off x="6217920" y="2807208"/>
+            <a:ext cx="5394960" cy="347472"/>
+          </a:xfrm>
+          <a:prstGeom prst="rect">
+            <a:avLst/>
+          </a:prstGeom>
+          <a:noFill/>
+          <a:ln/>
+        </p:spPr>
+        <p:txBody>
+          <a:bodyPr wrap="square" lIns="0" tIns="0" rIns="0" bIns="0" rtlCol="0" anchor="t"/>
+          <a:lstStyle/>
+          <a:p>
+            <a:pPr indent="0" marL="0">
+              <a:buNone/>
+            </a:pPr>
+            <a:r>
+              <a:rPr lang="en-US" sz="1700" b="1" dirty="0">
+                <a:solidFill>
+                  <a:schemeClr val="tx1"/>
+                </a:solidFill>
+              </a:rPr>
+              <a:t>Meta tooling · 25%</a:t>
+            </a:r>
+            <a:endParaRPr lang="en-US" sz="1700" dirty="0"/>
+          </a:p>
+        </p:txBody>
+      </p:sp>
+      <p:sp>
+        <p:nvSpPr>
+          <p:cNvPr id="15" name="Text 12"/>
+          <p:cNvSpPr txBox="1"/>
+          <p:nvPr/>
+        </p:nvSpPr>
+        <p:spPr>
+          <a:xfrm>
+            <a:off x="6217920" y="3172968"/>
+            <a:ext cx="5394960" cy="548640"/>
+          </a:xfrm>
+          <a:prstGeom prst="rect">
+            <a:avLst/>
+          </a:prstGeom>
+          <a:noFill/>
+          <a:ln/>
+        </p:spPr>
+        <p:txBody>
+          <a:bodyPr wrap="square" lIns="0" tIns="0" rIns="0" bIns="0" rtlCol="0" anchor="t"/>
+          <a:lstStyle/>
+          <a:p>
+            <a:pPr indent="0" marL="0">
+              <a:buNone/>
+            </a:pPr>
+            <a:r>
+              <a:rPr lang="en-US" sz="1400" dirty="0">
+                <a:solidFill>
+                  <a:schemeClr val="accent5"/>
+                </a:solidFill>
+              </a:rPr>
+              <a:t>Exemplar prompting, video tracking, Muse Spark as a tool-calling agent.</a:t>
+            </a:r>
+            <a:endParaRPr lang="en-US" sz="1400" dirty="0"/>
+          </a:p>
+        </p:txBody>
+      </p:sp>
+      <p:sp>
+        <p:nvSpPr>
+          <p:cNvPr id="16" name="legend-dot"/>
+          <p:cNvSpPr/>
+          <p:nvPr/>
+        </p:nvSpPr>
+        <p:spPr>
+          <a:xfrm>
+            <a:off x="5943600" y="3931920"/>
+            <a:ext cx="146304" cy="146304"/>
+          </a:xfrm>
+          <a:prstGeom prst="roundRect">
+            <a:avLst>
+              <a:gd name="adj" fmla="val 18750"/>
+            </a:avLst>
+          </a:prstGeom>
+          <a:solidFill>
+            <a:srgbClr val="60A5FA"/>
+          </a:solidFill>
+          <a:ln/>
+        </p:spPr>
+      </p:sp>
+      <p:sp>
+        <p:nvSpPr>
+          <p:cNvPr id="17" name="Text 14"/>
+          <p:cNvSpPr txBox="1"/>
+          <p:nvPr/>
+        </p:nvSpPr>
+        <p:spPr>
+          <a:xfrm>
+            <a:off x="6217920" y="3831336"/>
+            <a:ext cx="5394960" cy="347472"/>
+          </a:xfrm>
+          <a:prstGeom prst="rect">
+            <a:avLst/>
+          </a:prstGeom>
+          <a:noFill/>
+          <a:ln/>
+        </p:spPr>
+        <p:txBody>
+          <a:bodyPr wrap="square" lIns="0" tIns="0" rIns="0" bIns="0" rtlCol="0" anchor="t"/>
+          <a:lstStyle/>
+          <a:p>
+            <a:pPr indent="0" marL="0">
+              <a:buNone/>
+            </a:pPr>
+            <a:r>
+              <a:rPr lang="en-US" sz="1700" b="1" dirty="0">
+                <a:solidFill>
+                  <a:schemeClr val="tx1"/>
+                </a:solidFill>
+              </a:rPr>
+              <a:t>Demo · 25%</a:t>
+            </a:r>
+            <a:endParaRPr lang="en-US" sz="1700" dirty="0"/>
+          </a:p>
+        </p:txBody>
+      </p:sp>
+      <p:sp>
+        <p:nvSpPr>
+          <p:cNvPr id="18" name="Text 15"/>
+          <p:cNvSpPr txBox="1"/>
+          <p:nvPr/>
+        </p:nvSpPr>
+        <p:spPr>
+          <a:xfrm>
+            <a:off x="6217920" y="4197096"/>
+            <a:ext cx="5394960" cy="548640"/>
+          </a:xfrm>
+          <a:prstGeom prst="rect">
+            <a:avLst/>
+          </a:prstGeom>
+          <a:noFill/>
+          <a:ln/>
+        </p:spPr>
+        <p:txBody>
+          <a:bodyPr wrap="square" lIns="0" tIns="0" rIns="0" bIns="0" rtlCol="0" anchor="t"/>
+          <a:lstStyle/>
+          <a:p>
+            <a:pPr indent="0" marL="0">
+              <a:buNone/>
+            </a:pPr>
+            <a:r>
+              <a:rPr lang="en-US" sz="1400" dirty="0">
+                <a:solidFill>
+                  <a:schemeClr val="accent5"/>
+                </a:solidFill>
+              </a:rPr>
+              <a:t>Live on a real microscope, beside a microscopist's manual count.</a:t>
+            </a:r>
+            <a:endParaRPr lang="en-US" sz="1400" dirty="0"/>
+          </a:p>
+        </p:txBody>
+      </p:sp>
+      <p:sp>
+        <p:nvSpPr>
+          <p:cNvPr id="19" name="legend-dot"/>
+          <p:cNvSpPr/>
+          <p:nvPr/>
+        </p:nvSpPr>
+        <p:spPr>
+          <a:xfrm>
+            <a:off x="5943600" y="4956048"/>
+            <a:ext cx="146304" cy="146304"/>
+          </a:xfrm>
+          <a:prstGeom prst="roundRect">
+            <a:avLst>
+              <a:gd name="adj" fmla="val 18750"/>
+            </a:avLst>
+          </a:prstGeom>
+          <a:solidFill>
+            <a:srgbClr val="93C5FD"/>
+          </a:solidFill>
+          <a:ln/>
+        </p:spPr>
+      </p:sp>
+      <p:sp>
+        <p:nvSpPr>
+          <p:cNvPr id="20" name="Text 17"/>
+          <p:cNvSpPr txBox="1"/>
+          <p:nvPr/>
+        </p:nvSpPr>
+        <p:spPr>
+          <a:xfrm>
+            <a:off x="6217920" y="4855464"/>
+            <a:ext cx="5394960" cy="347472"/>
+          </a:xfrm>
+          <a:prstGeom prst="rect">
+            <a:avLst/>
+          </a:prstGeom>
+          <a:noFill/>
+          <a:ln/>
+        </p:spPr>
+        <p:txBody>
+          <a:bodyPr wrap="square" lIns="0" tIns="0" rIns="0" bIns="0" rtlCol="0" anchor="t"/>
+          <a:lstStyle/>
+          <a:p>
+            <a:pPr indent="0" marL="0">
+              <a:buNone/>
+            </a:pPr>
+            <a:r>
+              <a:rPr lang="en-US" sz="1700" b="1" dirty="0">
+                <a:solidFill>
+                  <a:schemeClr val="tx1"/>
+                </a:solidFill>
+              </a:rPr>
+              <a:t>Technical depth · 20%</a:t>
+            </a:r>
+            <a:endParaRPr lang="en-US" sz="1700" dirty="0"/>
+          </a:p>
+        </p:txBody>
+      </p:sp>
+      <p:sp>
+        <p:nvSpPr>
+          <p:cNvPr id="21" name="Text 18"/>
+          <p:cNvSpPr txBox="1"/>
+          <p:nvPr/>
+        </p:nvSpPr>
+        <p:spPr>
+          <a:xfrm>
+            <a:off x="6217920" y="5221224"/>
+            <a:ext cx="5394960" cy="548640"/>
           </a:xfrm>
           <a:prstGeom prst="rect">
             <a:avLst/>
@@ -13409,7 +13647,7 @@
     </a:clrScheme>
     <a:fontScheme name="Darubini Blue">
       <a:majorFont>
-        <a:latin typeface="Plus Jakarta Sans"/>
+        <a:latin typeface="Manrope"/>
         <a:ea typeface=""/>
         <a:cs typeface=""/>
         <a:font script="Jpan" typeface="游ゴシック Light"/>
@@ -13461,7 +13699,7 @@
         <a:font script="Tfng" typeface="Ebrima"/>
       </a:majorFont>
       <a:minorFont>
-        <a:latin typeface="Plus Jakarta Sans"/>
+        <a:latin typeface="Manrope"/>
         <a:ea typeface=""/>
         <a:cs typeface=""/>
         <a:font script="Jpan" typeface="游ゴシック"/>

</xml_diff>

<commit_message>
docs: rounded shadcn bars for the judging-weights chart in the deck
Co-Authored-By: Claude Opus 5.5 <noreply@anthropic.com>
Claude-Session: https://claude.ai/code/session_01RtzqifrKjueqJTPghCpXb1
</commit_message>
<xml_diff>
--- a/docs/proposal/Darubini-Proposal.pptx
+++ b/docs/proposal/Darubini-Proposal.pptx
@@ -118,34 +118,34 @@
   <p:extLst>
     <p:ext uri="{521415D9-36F7-43E2-AB2F-B90AF26B5E84}">
       <p14:sectionLst xmlns:p14="http://schemas.microsoft.com/office/powerpoint/2010/main">
-        <p14:section name="Opening" id="{fe5f6778-e8ca-1f07-b86a-570ea2ccc8da}">
+        <p14:section name="Opening" id="{1bd92d7b-1b50-aab6-644b-4eb8d7c8970e}">
           <p14:sldIdLst>
             <p14:sldId id="256"/>
           </p14:sldIdLst>
         </p14:section>
-        <p14:section name="Problem" id="{8fd7dc87-40ab-4387-a6de-05f0cf19ed3f}">
+        <p14:section name="Problem" id="{b581d66b-50cf-5a7b-41d6-841416278be2}">
           <p14:sldIdLst>
             <p14:sldId id="257"/>
           </p14:sldIdLst>
         </p14:section>
-        <p14:section name="Solution" id="{f3b3b03b-8185-a442-ba56-f4274cf2894d}">
+        <p14:section name="Solution" id="{3a51df01-9791-377c-4a7f-4d4f36a960f5}">
           <p14:sldIdLst>
             <p14:sldId id="258"/>
             <p14:sldId id="259"/>
           </p14:sldIdLst>
         </p14:section>
-        <p14:section name="Meta AI" id="{c1601780-c19e-bae4-a647-cfc82fd28686}">
+        <p14:section name="Meta AI" id="{816ba1e3-bc84-7fba-2693-9a0aa95fd578}">
           <p14:sldIdLst>
             <p14:sldId id="260"/>
           </p14:sldIdLst>
         </p14:section>
-        <p14:section name="Data and evaluation" id="{944a935f-0ce9-dd01-2ffa-7930833d265a}">
+        <p14:section name="Data and evaluation" id="{b727fa07-f8af-8bca-980a-c4cb707b41c9}">
           <p14:sldIdLst>
             <p14:sldId id="261"/>
             <p14:sldId id="262"/>
           </p14:sldIdLst>
         </p14:section>
-        <p14:section name="Strategy" id="{ca353bc0-1534-5b63-b3e1-b1889df209c3}">
+        <p14:section name="Strategy" id="{9b2b3787-06ad-fba0-11fa-af7a42d68faa}">
           <p14:sldIdLst>
             <p14:sldId id="263"/>
             <p14:sldId id="264"/>
@@ -153,7 +153,7 @@
             <p14:sldId id="266"/>
           </p14:sldIdLst>
         </p14:section>
-        <p14:section name="Close" id="{a8de9576-d013-01d9-bca3-e93eb1eba97c}">
+        <p14:section name="Close" id="{a009ba9f-ceae-b08a-1c84-1e821ba9040c}">
           <p14:sldIdLst>
             <p14:sldId id="267"/>
           </p14:sldIdLst>
@@ -165,295 +165,6 @@
     </p:ext>
   </p:extLst>
 </p:presentation>
-</file>
-
-<file path=ppt/charts/chart1.xml><?xml version="1.0" encoding="utf-8"?>
-<c:chartSpace xmlns:c="http://schemas.openxmlformats.org/drawingml/2006/chart" xmlns:a="http://schemas.openxmlformats.org/drawingml/2006/main" xmlns:r="http://schemas.openxmlformats.org/officeDocument/2006/relationships">
-  <c:date1904 val="0"/>
-  <c:roundedCorners val="1"/>
-  <c:chart>
-    <c:autoTitleDeleted val="1"/>
-    <c:plotArea>
-      <c:layout/>
-      <c:barChart>
-        <c:barDir val="bar"/>
-        <c:grouping val="clustered"/>
-        <c:varyColors val="0"/>
-        <c:ser>
-          <c:idx val="0"/>
-          <c:order val="0"/>
-          <c:tx>
-            <c:strRef>
-              <c:f>Sheet1!$B$1</c:f>
-              <c:strCache>
-                <c:ptCount val="1"/>
-                <c:pt idx="0">
-                  <c:v>Weight</c:v>
-                </c:pt>
-              </c:strCache>
-            </c:strRef>
-          </c:tx>
-          <c:spPr>
-            <a:solidFill>
-              <a:srgbClr val="2563EB"/>
-            </a:solidFill>
-            <a:effectLst/>
-          </c:spPr>
-          <c:invertIfNegative val="0"/>
-          <c:dLbls>
-            <c:numFmt formatCode="0&quot;%&quot;" sourceLinked="0"/>
-            <c:txPr>
-              <a:bodyPr/>
-              <a:lstStyle/>
-              <a:p>
-                <a:pPr>
-                  <a:defRPr b="1" i="0" strike="noStrike" sz="1200" u="none">
-                    <a:solidFill>
-                      <a:srgbClr val="0F172A"/>
-                    </a:solidFill>
-                    <a:latin typeface="+mn-lt"/>
-                  </a:defRPr>
-                </a:pPr>
-              </a:p>
-            </c:txPr>
-            <c:showLegendKey val="0"/>
-            <c:showVal val="1"/>
-            <c:showCatName val="0"/>
-            <c:showSerName val="0"/>
-            <c:showPercent val="0"/>
-            <c:showBubbleSize val="0"/>
-            <c:showLeaderLines val="0"/>
-          </c:dLbls>
-          <c:dPt>
-            <c:idx val="0"/>
-            <c:invertIfNegative val="0"/>
-            <c:bubble3D val="0"/>
-            <c:spPr>
-              <a:solidFill>
-                <a:srgbClr val="2563EB"/>
-              </a:solidFill>
-              <a:effectLst/>
-            </c:spPr>
-          </c:dPt>
-          <c:dPt>
-            <c:idx val="1"/>
-            <c:invertIfNegative val="0"/>
-            <c:bubble3D val="0"/>
-            <c:spPr>
-              <a:solidFill>
-                <a:srgbClr val="3B82F6"/>
-              </a:solidFill>
-              <a:effectLst/>
-            </c:spPr>
-          </c:dPt>
-          <c:dPt>
-            <c:idx val="2"/>
-            <c:invertIfNegative val="0"/>
-            <c:bubble3D val="0"/>
-            <c:spPr>
-              <a:solidFill>
-                <a:srgbClr val="60A5FA"/>
-              </a:solidFill>
-              <a:effectLst/>
-            </c:spPr>
-          </c:dPt>
-          <c:dPt>
-            <c:idx val="3"/>
-            <c:invertIfNegative val="0"/>
-            <c:bubble3D val="0"/>
-            <c:spPr>
-              <a:solidFill>
-                <a:srgbClr val="93C5FD"/>
-              </a:solidFill>
-              <a:effectLst/>
-            </c:spPr>
-          </c:dPt>
-          <c:cat>
-            <c:multiLvlStrRef>
-              <c:f>Sheet1!$A$2:$A$5</c:f>
-              <c:multiLvlStrCache>
-                <c:ptCount val="4"/>
-                <c:lvl>
-                  <c:pt idx="0">
-                    <c:v>Impact</c:v>
-                  </c:pt>
-                  <c:pt idx="1">
-                    <c:v>Meta tooling</c:v>
-                  </c:pt>
-                  <c:pt idx="2">
-                    <c:v>Demo</c:v>
-                  </c:pt>
-                  <c:pt idx="3">
-                    <c:v>Technical depth</c:v>
-                  </c:pt>
-                </c:lvl>
-              </c:multiLvlStrCache>
-            </c:multiLvlStrRef>
-          </c:cat>
-          <c:val>
-            <c:numRef>
-              <c:f>Sheet1!$B$2:$B$5</c:f>
-              <c:numCache>
-                <c:formatCode>General</c:formatCode>
-                <c:ptCount val="4"/>
-                <c:pt idx="0">
-                  <c:v>30</c:v>
-                </c:pt>
-                <c:pt idx="1">
-                  <c:v>25</c:v>
-                </c:pt>
-                <c:pt idx="2">
-                  <c:v>25</c:v>
-                </c:pt>
-                <c:pt idx="3">
-                  <c:v>20</c:v>
-                </c:pt>
-              </c:numCache>
-            </c:numRef>
-          </c:val>
-        </c:ser>
-        <c:dLbls>
-          <c:numFmt formatCode="0&quot;%&quot;" sourceLinked="0"/>
-          <c:txPr>
-            <a:bodyPr/>
-            <a:lstStyle/>
-            <a:p>
-              <a:pPr>
-                <a:defRPr b="1" i="0" strike="noStrike" sz="1200" u="none">
-                  <a:solidFill>
-                    <a:srgbClr val="0F172A"/>
-                  </a:solidFill>
-                  <a:latin typeface="+mn-lt"/>
-                </a:defRPr>
-              </a:pPr>
-            </a:p>
-          </c:txPr>
-          <c:showLegendKey val="0"/>
-          <c:showVal val="1"/>
-          <c:showCatName val="0"/>
-          <c:showSerName val="0"/>
-          <c:showPercent val="0"/>
-          <c:showBubbleSize val="0"/>
-          <c:showLeaderLines val="0"/>
-        </c:dLbls>
-        <c:gapWidth val="40"/>
-        <c:overlap val="0"/>
-        <c:axId val="2094734554"/>
-        <c:axId val="2094734552"/>
-        <c:axId val="2094734556"/>
-      </c:barChart>
-      <c:catAx>
-        <c:axId val="2094734554"/>
-        <c:scaling>
-          <c:orientation val="maxMin"/>
-        </c:scaling>
-        <c:delete val="0"/>
-        <c:axPos val="l"/>
-        <c:numFmt formatCode="General" sourceLinked="1"/>
-        <c:majorTickMark val="none"/>
-        <c:minorTickMark val="none"/>
-        <c:tickLblPos val="nextTo"/>
-        <c:spPr>
-          <a:ln w="12700" cap="flat">
-            <a:noFill/>
-            <a:prstDash val="solid"/>
-            <a:round/>
-          </a:ln>
-        </c:spPr>
-        <c:txPr>
-          <a:bodyPr/>
-          <a:lstStyle/>
-          <a:p>
-            <a:pPr>
-              <a:defRPr sz="1200" b="0" i="0" u="none" strike="noStrike">
-                <a:solidFill>
-                  <a:srgbClr val="64748B"/>
-                </a:solidFill>
-                <a:latin typeface="+mn-lt"/>
-              </a:defRPr>
-            </a:pPr>
-            <a:endParaRPr lang="en-US"/>
-          </a:p>
-        </c:txPr>
-        <c:crossAx val="2094734552"/>
-        <c:crosses val="autoZero"/>
-        <c:auto val="1"/>
-        <c:lblAlgn val="ctr"/>
-        <c:noMultiLvlLbl val="1"/>
-      </c:catAx>
-      <c:valAx>
-        <c:axId val="2094734552"/>
-        <c:scaling>
-          <c:orientation val="minMax"/>
-          <c:max val="35"/>
-          <c:min val="0"/>
-        </c:scaling>
-        <c:delete val="0"/>
-        <c:axPos val="b"/>
-        <c:majorGridlines>
-          <c:spPr>
-            <a:ln w="12700" cap="flat">
-              <a:solidFill>
-                <a:srgbClr val="E2E8F0"/>
-              </a:solidFill>
-              <a:prstDash val="dash"/>
-              <a:round/>
-            </a:ln>
-          </c:spPr>
-        </c:majorGridlines>
-        <c:numFmt formatCode="0" sourceLinked="0"/>
-        <c:majorTickMark val="none"/>
-        <c:minorTickMark val="none"/>
-        <c:tickLblPos val="low"/>
-        <c:spPr>
-          <a:ln w="12700" cap="flat">
-            <a:noFill/>
-            <a:prstDash val="solid"/>
-            <a:round/>
-          </a:ln>
-        </c:spPr>
-        <c:txPr>
-          <a:bodyPr/>
-          <a:lstStyle/>
-          <a:p>
-            <a:pPr>
-              <a:defRPr sz="1000" b="0" i="0" u="none" strike="noStrike">
-                <a:solidFill>
-                  <a:srgbClr val="64748B"/>
-                </a:solidFill>
-                <a:latin typeface="+mn-lt"/>
-              </a:defRPr>
-            </a:pPr>
-            <a:endParaRPr lang="en-US"/>
-          </a:p>
-        </c:txPr>
-        <c:crossAx val="2094734554"/>
-        <c:crosses val="autoZero"/>
-        <c:crossBetween val="between"/>
-        <c:majorUnit val="10"/>
-      </c:valAx>
-      <c:spPr>
-        <a:noFill/>
-        <a:ln>
-          <a:noFill/>
-        </a:ln>
-        <a:effectLst/>
-      </c:spPr>
-    </c:plotArea>
-    <c:plotVisOnly val="1"/>
-    <c:dispBlanksAs val="span"/>
-  </c:chart>
-  <c:spPr>
-    <a:noFill/>
-    <a:ln>
-      <a:noFill/>
-    </a:ln>
-    <a:effectLst/>
-  </c:spPr>
-  <c:externalData r:id="rId1">
-    <c:autoUpdate val="0"/>
-  </c:externalData>
-</c:chartSpace>
 </file>
 
 <file path=ppt/notesMasters/notesMaster1.xml><?xml version="1.0" encoding="utf-8"?>
@@ -15081,39 +14792,635 @@
           </a:p>
         </p:txBody>
       </p:sp>
-      <p:graphicFrame>
-        <p:nvGraphicFramePr>
-          <p:cNvPr id="8" name="weights-chart" descr=""/>
-          <p:cNvGraphicFramePr/>
-          <p:nvPr/>
-        </p:nvGraphicFramePr>
-        <p:xfrm>
-          <a:off x="822960" y="2743200"/>
-          <a:ext cx="5029200" cy="2514600"/>
-        </p:xfrm>
-        <a:graphic xmlns:a="http://schemas.openxmlformats.org/drawingml/2006/main">
-          <a:graphicData uri="http://schemas.openxmlformats.org/drawingml/2006/chart">
-            <c:chart xmlns:c="http://schemas.openxmlformats.org/drawingml/2006/chart" r:id="rId1"/>
-          </a:graphicData>
-        </a:graphic>
-      </p:graphicFrame>
+      <p:sp>
+        <p:nvSpPr>
+          <p:cNvPr id="8" name="gridline"/>
+          <p:cNvSpPr/>
+          <p:nvPr/>
+        </p:nvSpPr>
+        <p:spPr>
+          <a:xfrm>
+            <a:off x="2331720" y="2670048"/>
+            <a:ext cx="0" cy="2304288"/>
+          </a:xfrm>
+          <a:prstGeom prst="line">
+            <a:avLst/>
+          </a:prstGeom>
+          <a:noFill/>
+          <a:ln w="9525">
+            <a:solidFill>
+              <a:srgbClr val="E2E8F0"/>
+            </a:solidFill>
+            <a:prstDash val="dash"/>
+          </a:ln>
+        </p:spPr>
+      </p:sp>
+      <p:sp>
+        <p:nvSpPr>
+          <p:cNvPr id="9" name="Text 7"/>
+          <p:cNvSpPr txBox="1"/>
+          <p:nvPr/>
+        </p:nvSpPr>
+        <p:spPr>
+          <a:xfrm>
+            <a:off x="2057400" y="5010912"/>
+            <a:ext cx="548640" cy="219456"/>
+          </a:xfrm>
+          <a:prstGeom prst="rect">
+            <a:avLst/>
+          </a:prstGeom>
+          <a:noFill/>
+          <a:ln/>
+        </p:spPr>
+        <p:txBody>
+          <a:bodyPr wrap="square" lIns="0" tIns="0" rIns="0" bIns="0" rtlCol="0" anchor="t"/>
+          <a:lstStyle/>
+          <a:p>
+            <a:pPr algn="ctr" indent="0" marL="0">
+              <a:buNone/>
+            </a:pPr>
+            <a:r>
+              <a:rPr lang="en-US" sz="1000" dirty="0">
+                <a:solidFill>
+                  <a:srgbClr val="64748B"/>
+                </a:solidFill>
+              </a:rPr>
+              <a:t>0</a:t>
+            </a:r>
+            <a:endParaRPr lang="en-US" sz="1000" dirty="0"/>
+          </a:p>
+        </p:txBody>
+      </p:sp>
+      <p:sp>
+        <p:nvSpPr>
+          <p:cNvPr id="10" name="gridline"/>
+          <p:cNvSpPr/>
+          <p:nvPr/>
+        </p:nvSpPr>
+        <p:spPr>
+          <a:xfrm>
+            <a:off x="3285309" y="2670048"/>
+            <a:ext cx="0" cy="2304288"/>
+          </a:xfrm>
+          <a:prstGeom prst="line">
+            <a:avLst/>
+          </a:prstGeom>
+          <a:noFill/>
+          <a:ln w="9525">
+            <a:solidFill>
+              <a:srgbClr val="E2E8F0"/>
+            </a:solidFill>
+            <a:prstDash val="dash"/>
+          </a:ln>
+        </p:spPr>
+      </p:sp>
+      <p:sp>
+        <p:nvSpPr>
+          <p:cNvPr id="11" name="Text 9"/>
+          <p:cNvSpPr txBox="1"/>
+          <p:nvPr/>
+        </p:nvSpPr>
+        <p:spPr>
+          <a:xfrm>
+            <a:off x="3010989" y="5010912"/>
+            <a:ext cx="548640" cy="219456"/>
+          </a:xfrm>
+          <a:prstGeom prst="rect">
+            <a:avLst/>
+          </a:prstGeom>
+          <a:noFill/>
+          <a:ln/>
+        </p:spPr>
+        <p:txBody>
+          <a:bodyPr wrap="square" lIns="0" tIns="0" rIns="0" bIns="0" rtlCol="0" anchor="t"/>
+          <a:lstStyle/>
+          <a:p>
+            <a:pPr algn="ctr" indent="0" marL="0">
+              <a:buNone/>
+            </a:pPr>
+            <a:r>
+              <a:rPr lang="en-US" sz="1000" dirty="0">
+                <a:solidFill>
+                  <a:srgbClr val="64748B"/>
+                </a:solidFill>
+              </a:rPr>
+              <a:t>10</a:t>
+            </a:r>
+            <a:endParaRPr lang="en-US" sz="1000" dirty="0"/>
+          </a:p>
+        </p:txBody>
+      </p:sp>
+      <p:sp>
+        <p:nvSpPr>
+          <p:cNvPr id="12" name="gridline"/>
+          <p:cNvSpPr/>
+          <p:nvPr/>
+        </p:nvSpPr>
+        <p:spPr>
+          <a:xfrm>
+            <a:off x="4238897" y="2670048"/>
+            <a:ext cx="0" cy="2304288"/>
+          </a:xfrm>
+          <a:prstGeom prst="line">
+            <a:avLst/>
+          </a:prstGeom>
+          <a:noFill/>
+          <a:ln w="9525">
+            <a:solidFill>
+              <a:srgbClr val="E2E8F0"/>
+            </a:solidFill>
+            <a:prstDash val="dash"/>
+          </a:ln>
+        </p:spPr>
+      </p:sp>
+      <p:sp>
+        <p:nvSpPr>
+          <p:cNvPr id="13" name="Text 11"/>
+          <p:cNvSpPr txBox="1"/>
+          <p:nvPr/>
+        </p:nvSpPr>
+        <p:spPr>
+          <a:xfrm>
+            <a:off x="3964577" y="5010912"/>
+            <a:ext cx="548640" cy="219456"/>
+          </a:xfrm>
+          <a:prstGeom prst="rect">
+            <a:avLst/>
+          </a:prstGeom>
+          <a:noFill/>
+          <a:ln/>
+        </p:spPr>
+        <p:txBody>
+          <a:bodyPr wrap="square" lIns="0" tIns="0" rIns="0" bIns="0" rtlCol="0" anchor="t"/>
+          <a:lstStyle/>
+          <a:p>
+            <a:pPr algn="ctr" indent="0" marL="0">
+              <a:buNone/>
+            </a:pPr>
+            <a:r>
+              <a:rPr lang="en-US" sz="1000" dirty="0">
+                <a:solidFill>
+                  <a:srgbClr val="64748B"/>
+                </a:solidFill>
+              </a:rPr>
+              <a:t>20</a:t>
+            </a:r>
+            <a:endParaRPr lang="en-US" sz="1000" dirty="0"/>
+          </a:p>
+        </p:txBody>
+      </p:sp>
+      <p:sp>
+        <p:nvSpPr>
+          <p:cNvPr id="14" name="gridline"/>
+          <p:cNvSpPr/>
+          <p:nvPr/>
+        </p:nvSpPr>
+        <p:spPr>
+          <a:xfrm>
+            <a:off x="5192486" y="2670048"/>
+            <a:ext cx="0" cy="2304288"/>
+          </a:xfrm>
+          <a:prstGeom prst="line">
+            <a:avLst/>
+          </a:prstGeom>
+          <a:noFill/>
+          <a:ln w="9525">
+            <a:solidFill>
+              <a:srgbClr val="E2E8F0"/>
+            </a:solidFill>
+            <a:prstDash val="dash"/>
+          </a:ln>
+        </p:spPr>
+      </p:sp>
+      <p:sp>
+        <p:nvSpPr>
+          <p:cNvPr id="15" name="Text 13"/>
+          <p:cNvSpPr txBox="1"/>
+          <p:nvPr/>
+        </p:nvSpPr>
+        <p:spPr>
+          <a:xfrm>
+            <a:off x="4918166" y="5010912"/>
+            <a:ext cx="548640" cy="219456"/>
+          </a:xfrm>
+          <a:prstGeom prst="rect">
+            <a:avLst/>
+          </a:prstGeom>
+          <a:noFill/>
+          <a:ln/>
+        </p:spPr>
+        <p:txBody>
+          <a:bodyPr wrap="square" lIns="0" tIns="0" rIns="0" bIns="0" rtlCol="0" anchor="t"/>
+          <a:lstStyle/>
+          <a:p>
+            <a:pPr algn="ctr" indent="0" marL="0">
+              <a:buNone/>
+            </a:pPr>
+            <a:r>
+              <a:rPr lang="en-US" sz="1000" dirty="0">
+                <a:solidFill>
+                  <a:srgbClr val="64748B"/>
+                </a:solidFill>
+              </a:rPr>
+              <a:t>30</a:t>
+            </a:r>
+            <a:endParaRPr lang="en-US" sz="1000" dirty="0"/>
+          </a:p>
+        </p:txBody>
+      </p:sp>
+      <p:sp>
+        <p:nvSpPr>
+          <p:cNvPr id="16" name="Text 14"/>
+          <p:cNvSpPr txBox="1"/>
+          <p:nvPr/>
+        </p:nvSpPr>
+        <p:spPr>
+          <a:xfrm>
+            <a:off x="914400" y="2761488"/>
+            <a:ext cx="1280160" cy="420624"/>
+          </a:xfrm>
+          <a:prstGeom prst="rect">
+            <a:avLst/>
+          </a:prstGeom>
+          <a:noFill/>
+          <a:ln/>
+        </p:spPr>
+        <p:txBody>
+          <a:bodyPr wrap="square" lIns="0" tIns="0" rIns="0" bIns="0" rtlCol="0" anchor="ctr"/>
+          <a:lstStyle/>
+          <a:p>
+            <a:pPr algn="r" indent="0" marL="0">
+              <a:buNone/>
+            </a:pPr>
+            <a:r>
+              <a:rPr lang="en-US" sz="1200" dirty="0">
+                <a:solidFill>
+                  <a:srgbClr val="64748B"/>
+                </a:solidFill>
+              </a:rPr>
+              <a:t>Impact</a:t>
+            </a:r>
+            <a:endParaRPr lang="en-US" sz="1200" dirty="0"/>
+          </a:p>
+        </p:txBody>
+      </p:sp>
+      <p:sp>
+        <p:nvSpPr>
+          <p:cNvPr id="17" name="bar-Impact"/>
+          <p:cNvSpPr/>
+          <p:nvPr/>
+        </p:nvSpPr>
+        <p:spPr>
+          <a:xfrm>
+            <a:off x="2331720" y="2761488"/>
+            <a:ext cx="2860766" cy="420624"/>
+          </a:xfrm>
+          <a:prstGeom prst="roundRect">
+            <a:avLst>
+              <a:gd name="adj" fmla="val 17391"/>
+            </a:avLst>
+          </a:prstGeom>
+          <a:solidFill>
+            <a:srgbClr val="2563EB"/>
+          </a:solidFill>
+          <a:ln/>
+        </p:spPr>
+      </p:sp>
+      <p:sp>
+        <p:nvSpPr>
+          <p:cNvPr id="18" name="Text 16"/>
+          <p:cNvSpPr txBox="1"/>
+          <p:nvPr/>
+        </p:nvSpPr>
+        <p:spPr>
+          <a:xfrm>
+            <a:off x="2331720" y="2761488"/>
+            <a:ext cx="2732750" cy="420624"/>
+          </a:xfrm>
+          <a:prstGeom prst="rect">
+            <a:avLst/>
+          </a:prstGeom>
+          <a:noFill/>
+          <a:ln/>
+        </p:spPr>
+        <p:txBody>
+          <a:bodyPr wrap="square" lIns="0" tIns="0" rIns="0" bIns="0" rtlCol="0" anchor="ctr"/>
+          <a:lstStyle/>
+          <a:p>
+            <a:pPr algn="r" indent="0" marL="0">
+              <a:buNone/>
+            </a:pPr>
+            <a:r>
+              <a:rPr lang="en-US" sz="1200" b="1" dirty="0">
+                <a:solidFill>
+                  <a:srgbClr val="FFFFFF"/>
+                </a:solidFill>
+              </a:rPr>
+              <a:t>30%</a:t>
+            </a:r>
+            <a:endParaRPr lang="en-US" sz="1200" dirty="0"/>
+          </a:p>
+        </p:txBody>
+      </p:sp>
+      <p:sp>
+        <p:nvSpPr>
+          <p:cNvPr id="19" name="Text 17"/>
+          <p:cNvSpPr txBox="1"/>
+          <p:nvPr/>
+        </p:nvSpPr>
+        <p:spPr>
+          <a:xfrm>
+            <a:off x="914400" y="3328416"/>
+            <a:ext cx="1280160" cy="420624"/>
+          </a:xfrm>
+          <a:prstGeom prst="rect">
+            <a:avLst/>
+          </a:prstGeom>
+          <a:noFill/>
+          <a:ln/>
+        </p:spPr>
+        <p:txBody>
+          <a:bodyPr wrap="square" lIns="0" tIns="0" rIns="0" bIns="0" rtlCol="0" anchor="ctr"/>
+          <a:lstStyle/>
+          <a:p>
+            <a:pPr algn="r" indent="0" marL="0">
+              <a:buNone/>
+            </a:pPr>
+            <a:r>
+              <a:rPr lang="en-US" sz="1200" dirty="0">
+                <a:solidFill>
+                  <a:srgbClr val="64748B"/>
+                </a:solidFill>
+              </a:rPr>
+              <a:t>Meta tooling</a:t>
+            </a:r>
+            <a:endParaRPr lang="en-US" sz="1200" dirty="0"/>
+          </a:p>
+        </p:txBody>
+      </p:sp>
+      <p:sp>
+        <p:nvSpPr>
+          <p:cNvPr id="20" name="bar-Meta tooling"/>
+          <p:cNvSpPr/>
+          <p:nvPr/>
+        </p:nvSpPr>
+        <p:spPr>
+          <a:xfrm>
+            <a:off x="2331720" y="3328416"/>
+            <a:ext cx="2383971" cy="420624"/>
+          </a:xfrm>
+          <a:prstGeom prst="roundRect">
+            <a:avLst>
+              <a:gd name="adj" fmla="val 17391"/>
+            </a:avLst>
+          </a:prstGeom>
+          <a:solidFill>
+            <a:srgbClr val="3B82F6"/>
+          </a:solidFill>
+          <a:ln/>
+        </p:spPr>
+      </p:sp>
+      <p:sp>
+        <p:nvSpPr>
+          <p:cNvPr id="21" name="Text 19"/>
+          <p:cNvSpPr txBox="1"/>
+          <p:nvPr/>
+        </p:nvSpPr>
+        <p:spPr>
+          <a:xfrm>
+            <a:off x="2331720" y="3328416"/>
+            <a:ext cx="2255955" cy="420624"/>
+          </a:xfrm>
+          <a:prstGeom prst="rect">
+            <a:avLst/>
+          </a:prstGeom>
+          <a:noFill/>
+          <a:ln/>
+        </p:spPr>
+        <p:txBody>
+          <a:bodyPr wrap="square" lIns="0" tIns="0" rIns="0" bIns="0" rtlCol="0" anchor="ctr"/>
+          <a:lstStyle/>
+          <a:p>
+            <a:pPr algn="r" indent="0" marL="0">
+              <a:buNone/>
+            </a:pPr>
+            <a:r>
+              <a:rPr lang="en-US" sz="1200" b="1" dirty="0">
+                <a:solidFill>
+                  <a:srgbClr val="FFFFFF"/>
+                </a:solidFill>
+              </a:rPr>
+              <a:t>25%</a:t>
+            </a:r>
+            <a:endParaRPr lang="en-US" sz="1200" dirty="0"/>
+          </a:p>
+        </p:txBody>
+      </p:sp>
+      <p:sp>
+        <p:nvSpPr>
+          <p:cNvPr id="22" name="Text 20"/>
+          <p:cNvSpPr txBox="1"/>
+          <p:nvPr/>
+        </p:nvSpPr>
+        <p:spPr>
+          <a:xfrm>
+            <a:off x="914400" y="3895344"/>
+            <a:ext cx="1280160" cy="420624"/>
+          </a:xfrm>
+          <a:prstGeom prst="rect">
+            <a:avLst/>
+          </a:prstGeom>
+          <a:noFill/>
+          <a:ln/>
+        </p:spPr>
+        <p:txBody>
+          <a:bodyPr wrap="square" lIns="0" tIns="0" rIns="0" bIns="0" rtlCol="0" anchor="ctr"/>
+          <a:lstStyle/>
+          <a:p>
+            <a:pPr algn="r" indent="0" marL="0">
+              <a:buNone/>
+            </a:pPr>
+            <a:r>
+              <a:rPr lang="en-US" sz="1200" dirty="0">
+                <a:solidFill>
+                  <a:srgbClr val="64748B"/>
+                </a:solidFill>
+              </a:rPr>
+              <a:t>Demo</a:t>
+            </a:r>
+            <a:endParaRPr lang="en-US" sz="1200" dirty="0"/>
+          </a:p>
+        </p:txBody>
+      </p:sp>
+      <p:sp>
+        <p:nvSpPr>
+          <p:cNvPr id="23" name="bar-Demo"/>
+          <p:cNvSpPr/>
+          <p:nvPr/>
+        </p:nvSpPr>
+        <p:spPr>
+          <a:xfrm>
+            <a:off x="2331720" y="3895344"/>
+            <a:ext cx="2383971" cy="420624"/>
+          </a:xfrm>
+          <a:prstGeom prst="roundRect">
+            <a:avLst>
+              <a:gd name="adj" fmla="val 17391"/>
+            </a:avLst>
+          </a:prstGeom>
+          <a:solidFill>
+            <a:srgbClr val="60A5FA"/>
+          </a:solidFill>
+          <a:ln/>
+        </p:spPr>
+      </p:sp>
+      <p:sp>
+        <p:nvSpPr>
+          <p:cNvPr id="24" name="Text 22"/>
+          <p:cNvSpPr txBox="1"/>
+          <p:nvPr/>
+        </p:nvSpPr>
+        <p:spPr>
+          <a:xfrm>
+            <a:off x="2331720" y="3895344"/>
+            <a:ext cx="2255955" cy="420624"/>
+          </a:xfrm>
+          <a:prstGeom prst="rect">
+            <a:avLst/>
+          </a:prstGeom>
+          <a:noFill/>
+          <a:ln/>
+        </p:spPr>
+        <p:txBody>
+          <a:bodyPr wrap="square" lIns="0" tIns="0" rIns="0" bIns="0" rtlCol="0" anchor="ctr"/>
+          <a:lstStyle/>
+          <a:p>
+            <a:pPr algn="r" indent="0" marL="0">
+              <a:buNone/>
+            </a:pPr>
+            <a:r>
+              <a:rPr lang="en-US" sz="1200" b="1" dirty="0">
+                <a:solidFill>
+                  <a:srgbClr val="0F172A"/>
+                </a:solidFill>
+              </a:rPr>
+              <a:t>25%</a:t>
+            </a:r>
+            <a:endParaRPr lang="en-US" sz="1200" dirty="0"/>
+          </a:p>
+        </p:txBody>
+      </p:sp>
+      <p:sp>
+        <p:nvSpPr>
+          <p:cNvPr id="25" name="Text 23"/>
+          <p:cNvSpPr txBox="1"/>
+          <p:nvPr/>
+        </p:nvSpPr>
+        <p:spPr>
+          <a:xfrm>
+            <a:off x="914400" y="4462272"/>
+            <a:ext cx="1280160" cy="420624"/>
+          </a:xfrm>
+          <a:prstGeom prst="rect">
+            <a:avLst/>
+          </a:prstGeom>
+          <a:noFill/>
+          <a:ln/>
+        </p:spPr>
+        <p:txBody>
+          <a:bodyPr wrap="square" lIns="0" tIns="0" rIns="0" bIns="0" rtlCol="0" anchor="ctr"/>
+          <a:lstStyle/>
+          <a:p>
+            <a:pPr algn="r" indent="0" marL="0">
+              <a:buNone/>
+            </a:pPr>
+            <a:r>
+              <a:rPr lang="en-US" sz="1200" dirty="0">
+                <a:solidFill>
+                  <a:srgbClr val="64748B"/>
+                </a:solidFill>
+              </a:rPr>
+              <a:t>Technical depth</a:t>
+            </a:r>
+            <a:endParaRPr lang="en-US" sz="1200" dirty="0"/>
+          </a:p>
+        </p:txBody>
+      </p:sp>
+      <p:sp>
+        <p:nvSpPr>
+          <p:cNvPr id="26" name="bar-Technical depth"/>
+          <p:cNvSpPr/>
+          <p:nvPr/>
+        </p:nvSpPr>
+        <p:spPr>
+          <a:xfrm>
+            <a:off x="2331720" y="4462272"/>
+            <a:ext cx="1907177" cy="420624"/>
+          </a:xfrm>
+          <a:prstGeom prst="roundRect">
+            <a:avLst>
+              <a:gd name="adj" fmla="val 17391"/>
+            </a:avLst>
+          </a:prstGeom>
+          <a:solidFill>
+            <a:srgbClr val="93C5FD"/>
+          </a:solidFill>
+          <a:ln/>
+        </p:spPr>
+      </p:sp>
+      <p:sp>
+        <p:nvSpPr>
+          <p:cNvPr id="27" name="Text 25"/>
+          <p:cNvSpPr txBox="1"/>
+          <p:nvPr/>
+        </p:nvSpPr>
+        <p:spPr>
+          <a:xfrm>
+            <a:off x="2331720" y="4462272"/>
+            <a:ext cx="1779161" cy="420624"/>
+          </a:xfrm>
+          <a:prstGeom prst="rect">
+            <a:avLst/>
+          </a:prstGeom>
+          <a:noFill/>
+          <a:ln/>
+        </p:spPr>
+        <p:txBody>
+          <a:bodyPr wrap="square" lIns="0" tIns="0" rIns="0" bIns="0" rtlCol="0" anchor="ctr"/>
+          <a:lstStyle/>
+          <a:p>
+            <a:pPr algn="r" indent="0" marL="0">
+              <a:buNone/>
+            </a:pPr>
+            <a:r>
+              <a:rPr lang="en-US" sz="1200" b="1" dirty="0">
+                <a:solidFill>
+                  <a:srgbClr val="0F172A"/>
+                </a:solidFill>
+              </a:rPr>
+              <a:t>20%</a:t>
+            </a:r>
+            <a:endParaRPr lang="en-US" sz="1200" dirty="0"/>
+          </a:p>
+        </p:txBody>
+      </p:sp>
       <p:pic>
         <p:nvPicPr>
-          <p:cNvPr id="9" name="trend" descr="preencoded.png">    </p:cNvPr>
+          <p:cNvPr id="28" name="trend" descr="preencoded.png">    </p:cNvPr>
           <p:cNvPicPr>
             <a:picLocks noChangeAspect="1"/>
           </p:cNvPicPr>
           <p:nvPr/>
         </p:nvPicPr>
         <p:blipFill>
-          <a:blip r:embed="rId2"/>
+          <a:blip r:embed="rId1"/>
           <a:stretch>
             <a:fillRect/>
           </a:stretch>
         </p:blipFill>
         <p:spPr>
           <a:xfrm>
-            <a:off x="960120" y="5422392"/>
+            <a:off x="960120" y="5468112"/>
             <a:ext cx="182880" cy="182880"/>
           </a:xfrm>
           <a:prstGeom prst="rect">
@@ -15123,13 +15430,13 @@
       </p:pic>
       <p:sp>
         <p:nvSpPr>
-          <p:cNvPr id="10" name="Text 6"/>
-          <p:cNvSpPr txBox="1"/>
-          <p:nvPr/>
-        </p:nvSpPr>
-        <p:spPr>
-          <a:xfrm>
-            <a:off x="1234440" y="5394960"/>
+          <p:cNvPr id="29" name="Text 26"/>
+          <p:cNvSpPr txBox="1"/>
+          <p:nvPr/>
+        </p:nvSpPr>
+        <p:spPr>
+          <a:xfrm>
+            <a:off x="1234440" y="5440680"/>
             <a:ext cx="4572000" cy="256032"/>
           </a:xfrm>
           <a:prstGeom prst="rect">
@@ -15159,13 +15466,13 @@
       </p:sp>
       <p:sp>
         <p:nvSpPr>
-          <p:cNvPr id="11" name="Text 7"/>
-          <p:cNvSpPr txBox="1"/>
-          <p:nvPr/>
-        </p:nvSpPr>
-        <p:spPr>
-          <a:xfrm>
-            <a:off x="960120" y="5669280"/>
+          <p:cNvPr id="30" name="Text 27"/>
+          <p:cNvSpPr txBox="1"/>
+          <p:nvPr/>
+        </p:nvSpPr>
+        <p:spPr>
+          <a:xfrm>
+            <a:off x="960120" y="5705856"/>
             <a:ext cx="4572000" cy="237744"/>
           </a:xfrm>
           <a:prstGeom prst="rect">
@@ -15195,7 +15502,7 @@
       </p:sp>
       <p:sp>
         <p:nvSpPr>
-          <p:cNvPr id="12" name="legend-card"/>
+          <p:cNvPr id="31" name="legend-card"/>
           <p:cNvSpPr/>
           <p:nvPr/>
         </p:nvSpPr>
@@ -15229,7 +15536,7 @@
       </p:sp>
       <p:sp>
         <p:nvSpPr>
-          <p:cNvPr id="13" name="legend-dot"/>
+          <p:cNvPr id="32" name="legend-dot"/>
           <p:cNvSpPr/>
           <p:nvPr/>
         </p:nvSpPr>
@@ -15251,7 +15558,7 @@
       </p:sp>
       <p:sp>
         <p:nvSpPr>
-          <p:cNvPr id="14" name="Text 10"/>
+          <p:cNvPr id="33" name="Text 30"/>
           <p:cNvSpPr txBox="1"/>
           <p:nvPr/>
         </p:nvSpPr>
@@ -15287,7 +15594,7 @@
       </p:sp>
       <p:sp>
         <p:nvSpPr>
-          <p:cNvPr id="15" name="Text 11"/>
+          <p:cNvPr id="34" name="Text 31"/>
           <p:cNvSpPr txBox="1"/>
           <p:nvPr/>
         </p:nvSpPr>
@@ -15323,7 +15630,7 @@
       </p:sp>
       <p:sp>
         <p:nvSpPr>
-          <p:cNvPr id="16" name="Text 12"/>
+          <p:cNvPr id="35" name="Text 32"/>
           <p:cNvSpPr txBox="1"/>
           <p:nvPr/>
         </p:nvSpPr>
@@ -15359,7 +15666,7 @@
       </p:sp>
       <p:sp>
         <p:nvSpPr>
-          <p:cNvPr id="17" name="divider"/>
+          <p:cNvPr id="36" name="divider"/>
           <p:cNvSpPr/>
           <p:nvPr/>
         </p:nvSpPr>
@@ -15382,7 +15689,7 @@
       </p:sp>
       <p:sp>
         <p:nvSpPr>
-          <p:cNvPr id="18" name="legend-dot"/>
+          <p:cNvPr id="37" name="legend-dot"/>
           <p:cNvSpPr/>
           <p:nvPr/>
         </p:nvSpPr>
@@ -15404,7 +15711,7 @@
       </p:sp>
       <p:sp>
         <p:nvSpPr>
-          <p:cNvPr id="19" name="Text 15"/>
+          <p:cNvPr id="38" name="Text 35"/>
           <p:cNvSpPr txBox="1"/>
           <p:nvPr/>
         </p:nvSpPr>
@@ -15440,7 +15747,7 @@
       </p:sp>
       <p:sp>
         <p:nvSpPr>
-          <p:cNvPr id="20" name="Text 16"/>
+          <p:cNvPr id="39" name="Text 36"/>
           <p:cNvSpPr txBox="1"/>
           <p:nvPr/>
         </p:nvSpPr>
@@ -15476,7 +15783,7 @@
       </p:sp>
       <p:sp>
         <p:nvSpPr>
-          <p:cNvPr id="21" name="Text 17"/>
+          <p:cNvPr id="40" name="Text 37"/>
           <p:cNvSpPr txBox="1"/>
           <p:nvPr/>
         </p:nvSpPr>
@@ -15512,7 +15819,7 @@
       </p:sp>
       <p:sp>
         <p:nvSpPr>
-          <p:cNvPr id="22" name="divider"/>
+          <p:cNvPr id="41" name="divider"/>
           <p:cNvSpPr/>
           <p:nvPr/>
         </p:nvSpPr>
@@ -15535,7 +15842,7 @@
       </p:sp>
       <p:sp>
         <p:nvSpPr>
-          <p:cNvPr id="23" name="legend-dot"/>
+          <p:cNvPr id="42" name="legend-dot"/>
           <p:cNvSpPr/>
           <p:nvPr/>
         </p:nvSpPr>
@@ -15557,7 +15864,7 @@
       </p:sp>
       <p:sp>
         <p:nvSpPr>
-          <p:cNvPr id="24" name="Text 20"/>
+          <p:cNvPr id="43" name="Text 40"/>
           <p:cNvSpPr txBox="1"/>
           <p:nvPr/>
         </p:nvSpPr>
@@ -15593,7 +15900,7 @@
       </p:sp>
       <p:sp>
         <p:nvSpPr>
-          <p:cNvPr id="25" name="Text 21"/>
+          <p:cNvPr id="44" name="Text 41"/>
           <p:cNvSpPr txBox="1"/>
           <p:nvPr/>
         </p:nvSpPr>
@@ -15629,7 +15936,7 @@
       </p:sp>
       <p:sp>
         <p:nvSpPr>
-          <p:cNvPr id="26" name="Text 22"/>
+          <p:cNvPr id="45" name="Text 42"/>
           <p:cNvSpPr txBox="1"/>
           <p:nvPr/>
         </p:nvSpPr>
@@ -15665,7 +15972,7 @@
       </p:sp>
       <p:sp>
         <p:nvSpPr>
-          <p:cNvPr id="27" name="divider"/>
+          <p:cNvPr id="46" name="divider"/>
           <p:cNvSpPr/>
           <p:nvPr/>
         </p:nvSpPr>
@@ -15688,7 +15995,7 @@
       </p:sp>
       <p:sp>
         <p:nvSpPr>
-          <p:cNvPr id="28" name="legend-dot"/>
+          <p:cNvPr id="47" name="legend-dot"/>
           <p:cNvSpPr/>
           <p:nvPr/>
         </p:nvSpPr>
@@ -15710,7 +16017,7 @@
       </p:sp>
       <p:sp>
         <p:nvSpPr>
-          <p:cNvPr id="29" name="Text 25"/>
+          <p:cNvPr id="48" name="Text 45"/>
           <p:cNvSpPr txBox="1"/>
           <p:nvPr/>
         </p:nvSpPr>
@@ -15746,7 +16053,7 @@
       </p:sp>
       <p:sp>
         <p:nvSpPr>
-          <p:cNvPr id="30" name="Text 26"/>
+          <p:cNvPr id="49" name="Text 46"/>
           <p:cNvSpPr txBox="1"/>
           <p:nvPr/>
         </p:nvSpPr>
@@ -15782,7 +16089,7 @@
       </p:sp>
       <p:sp>
         <p:nvSpPr>
-          <p:cNvPr id="31" name="Text 27"/>
+          <p:cNvPr id="50" name="Text 47"/>
           <p:cNvSpPr txBox="1"/>
           <p:nvPr/>
         </p:nvSpPr>

</xml_diff>